<commit_message>
Regenerate the presentation and HLD for the September portal
The key-innovation slide told the August story: a 5 Mb/s per-IP ceiling and
48 s to first frame on a portal that no longer exists. The stronger and now
true story is that the sandbox changed protocol, host and access model three
times during the build and only the adapter and discovery layer changed with
it, so that is what the slide and the HLD's integration section now say. Both
also state how source credentials are kept out of the registry and logs.

The demo shot script names the current ports, the env file the credentials
live in, and the cameras worth pinning before recording. The dev-server
config runs the API on 8010 (a Windows service holds 8000 on this machine)
with a wider ingest budget for the multi-camera trace run.

Co-Authored-By: Claude Fable 5.1 <noreply@anthropic.com>
</commit_message>
<xml_diff>
--- a/submission/SUTRA_Solution_Presentation.pptx
+++ b/submission/SUTRA_Solution_Presentation.pptx
@@ -118,278 +118,6 @@
 </p:presentation>
 </file>
 
-<file path=ppt/charts/chart1.xml><?xml version="1.0" encoding="utf-8"?>
-<c:chartSpace xmlns:c="http://schemas.openxmlformats.org/drawingml/2006/chart" xmlns:a="http://schemas.openxmlformats.org/drawingml/2006/main" xmlns:r="http://schemas.openxmlformats.org/officeDocument/2006/relationships">
-  <c:date1904 val="0"/>
-  <c:roundedCorners val="1"/>
-  <c:chart>
-    <c:title>
-      <c:tx>
-        <c:rich>
-          <a:bodyPr/>
-          <a:lstStyle/>
-          <a:p>
-            <a:pPr>
-              <a:defRPr sz="1200" b="0" i="0" u="none" strike="noStrike">
-                <a:solidFill>
-                  <a:srgbClr val="FFFFFF"/>
-                </a:solidFill>
-                <a:latin typeface="Calibri"/>
-              </a:defRPr>
-            </a:pPr>
-            <a:r>
-              <a:rPr sz="1200" b="0" i="0" u="none" strike="noStrike">
-                <a:solidFill>
-                  <a:srgbClr val="FFFFFF"/>
-                </a:solidFill>
-                <a:latin typeface="Calibri"/>
-              </a:rPr>
-              <a:t>Portal throughput does not scale with connections</a:t>
-            </a:r>
-          </a:p>
-        </c:rich>
-      </c:tx>
-      <c:layout/>
-      <c:overlay val="0"/>
-    </c:title>
-    <c:autoTitleDeleted val="0"/>
-    <c:plotArea>
-      <c:layout/>
-      <c:barChart>
-        <c:barDir val="col"/>
-        <c:grouping val="clustered"/>
-        <c:varyColors val="0"/>
-        <c:ser>
-          <c:idx val="0"/>
-          <c:order val="0"/>
-          <c:tx>
-            <c:strRef>
-              <c:f>Sheet1!$B$1</c:f>
-              <c:strCache>
-                <c:ptCount val="1"/>
-                <c:pt idx="0">
-                  <c:v>Aggregate delivered (Mbps)</c:v>
-                </c:pt>
-              </c:strCache>
-            </c:strRef>
-          </c:tx>
-          <c:spPr>
-            <a:solidFill>
-              <a:srgbClr val="F0A428"/>
-            </a:solidFill>
-            <a:effectLst/>
-          </c:spPr>
-          <c:invertIfNegative val="0"/>
-          <c:dLbls>
-            <c:numFmt formatCode="0.0" sourceLinked="0"/>
-            <c:txPr>
-              <a:bodyPr/>
-              <a:lstStyle/>
-              <a:p>
-                <a:pPr>
-                  <a:defRPr b="0" i="0" strike="noStrike" sz="1100" u="none">
-                    <a:solidFill>
-                      <a:srgbClr val="FFFFFF"/>
-                    </a:solidFill>
-                    <a:latin typeface="Calibri"/>
-                  </a:defRPr>
-                </a:pPr>
-              </a:p>
-            </c:txPr>
-            <c:showLegendKey val="0"/>
-            <c:showVal val="1"/>
-            <c:showCatName val="0"/>
-            <c:showSerName val="0"/>
-            <c:showPercent val="0"/>
-            <c:showBubbleSize val="0"/>
-            <c:showLeaderLines val="0"/>
-          </c:dLbls>
-          <c:cat>
-            <c:multiLvlStrRef>
-              <c:f>Sheet1!$A$2:$A$4</c:f>
-              <c:multiLvlStrCache>
-                <c:ptCount val="3"/>
-                <c:lvl>
-                  <c:pt idx="0">
-                    <c:v>4 streams</c:v>
-                  </c:pt>
-                  <c:pt idx="1">
-                    <c:v>10 streams</c:v>
-                  </c:pt>
-                  <c:pt idx="2">
-                    <c:v>20 streams</c:v>
-                  </c:pt>
-                </c:lvl>
-              </c:multiLvlStrCache>
-            </c:multiLvlStrRef>
-          </c:cat>
-          <c:val>
-            <c:numRef>
-              <c:f>Sheet1!$B$2:$B$4</c:f>
-              <c:numCache>
-                <c:formatCode>General</c:formatCode>
-                <c:ptCount val="3"/>
-                <c:pt idx="0">
-                  <c:v>1.5</c:v>
-                </c:pt>
-                <c:pt idx="1">
-                  <c:v>5</c:v>
-                </c:pt>
-                <c:pt idx="2">
-                  <c:v>5.4</c:v>
-                </c:pt>
-              </c:numCache>
-            </c:numRef>
-          </c:val>
-        </c:ser>
-        <c:dLbls>
-          <c:numFmt formatCode="0.0" sourceLinked="0"/>
-          <c:txPr>
-            <a:bodyPr/>
-            <a:lstStyle/>
-            <a:p>
-              <a:pPr>
-                <a:defRPr b="0" i="0" strike="noStrike" sz="1100" u="none">
-                  <a:solidFill>
-                    <a:srgbClr val="FFFFFF"/>
-                  </a:solidFill>
-                  <a:latin typeface="Calibri"/>
-                </a:defRPr>
-              </a:pPr>
-            </a:p>
-          </c:txPr>
-          <c:showLegendKey val="0"/>
-          <c:showVal val="1"/>
-          <c:showCatName val="0"/>
-          <c:showSerName val="0"/>
-          <c:showPercent val="0"/>
-          <c:showBubbleSize val="0"/>
-          <c:showLeaderLines val="0"/>
-        </c:dLbls>
-        <c:gapWidth val="150"/>
-        <c:overlap val="0"/>
-        <c:axId val="2094734554"/>
-        <c:axId val="2094734552"/>
-        <c:axId val="2094734556"/>
-      </c:barChart>
-      <c:catAx>
-        <c:axId val="2094734554"/>
-        <c:scaling>
-          <c:orientation val="minMax"/>
-        </c:scaling>
-        <c:delete val="0"/>
-        <c:axPos val="b"/>
-        <c:numFmt formatCode="General" sourceLinked="1"/>
-        <c:majorTickMark val="out"/>
-        <c:minorTickMark val="none"/>
-        <c:tickLblPos val="low"/>
-        <c:spPr>
-          <a:ln w="12700" cap="flat">
-            <a:solidFill>
-              <a:srgbClr val="888888"/>
-            </a:solidFill>
-            <a:prstDash val="solid"/>
-            <a:round/>
-          </a:ln>
-        </c:spPr>
-        <c:txPr>
-          <a:bodyPr/>
-          <a:lstStyle/>
-          <a:p>
-            <a:pPr>
-              <a:defRPr sz="1100" b="0" i="0" u="none" strike="noStrike">
-                <a:solidFill>
-                  <a:srgbClr val="CBD8E8"/>
-                </a:solidFill>
-                <a:latin typeface="Calibri"/>
-              </a:defRPr>
-            </a:pPr>
-            <a:endParaRPr lang="en-US"/>
-          </a:p>
-        </c:txPr>
-        <c:crossAx val="2094734552"/>
-        <c:crosses val="autoZero"/>
-        <c:auto val="1"/>
-        <c:lblAlgn val="ctr"/>
-        <c:noMultiLvlLbl val="1"/>
-      </c:catAx>
-      <c:valAx>
-        <c:axId val="2094734552"/>
-        <c:scaling>
-          <c:orientation val="minMax"/>
-          <c:max val="7"/>
-        </c:scaling>
-        <c:delete val="0"/>
-        <c:axPos val="l"/>
-        <c:majorGridlines>
-          <c:spPr>
-            <a:ln w="12700" cap="flat">
-              <a:solidFill>
-                <a:srgbClr val="24405E"/>
-              </a:solidFill>
-              <a:prstDash val="solid"/>
-              <a:round/>
-            </a:ln>
-          </c:spPr>
-        </c:majorGridlines>
-        <c:numFmt formatCode="General" sourceLinked="0"/>
-        <c:majorTickMark val="out"/>
-        <c:minorTickMark val="none"/>
-        <c:tickLblPos val="nextTo"/>
-        <c:spPr>
-          <a:ln w="12700" cap="flat">
-            <a:solidFill>
-              <a:srgbClr val="888888"/>
-            </a:solidFill>
-            <a:prstDash val="solid"/>
-            <a:round/>
-          </a:ln>
-        </c:spPr>
-        <c:txPr>
-          <a:bodyPr/>
-          <a:lstStyle/>
-          <a:p>
-            <a:pPr>
-              <a:defRPr sz="1000" b="0" i="0" u="none" strike="noStrike">
-                <a:solidFill>
-                  <a:srgbClr val="8A9BB0"/>
-                </a:solidFill>
-                <a:latin typeface="Calibri"/>
-              </a:defRPr>
-            </a:pPr>
-            <a:endParaRPr lang="en-US"/>
-          </a:p>
-        </c:txPr>
-        <c:crossAx val="2094734554"/>
-        <c:crosses val="autoZero"/>
-        <c:crossBetween val="between"/>
-      </c:valAx>
-      <c:spPr>
-        <a:solidFill>
-          <a:srgbClr val="0E1A2B"/>
-        </a:solidFill>
-        <a:ln>
-          <a:noFill/>
-        </a:ln>
-        <a:effectLst/>
-      </c:spPr>
-    </c:plotArea>
-    <c:plotVisOnly val="1"/>
-    <c:dispBlanksAs val="span"/>
-  </c:chart>
-  <c:spPr>
-    <a:noFill/>
-    <a:ln>
-      <a:noFill/>
-    </a:ln>
-    <a:effectLst/>
-  </c:spPr>
-  <c:externalData r:id="rId1">
-    <c:autoUpdate val="0"/>
-  </c:externalData>
-</c:chartSpace>
-</file>
-
 <file path=ppt/notesMasters/notesMaster1.xml><?xml version="1.0" encoding="utf-8"?>
 <p:notesMaster xmlns:a="http://schemas.openxmlformats.org/drawingml/2006/main" xmlns:r="http://schemas.openxmlformats.org/officeDocument/2006/relationships" xmlns:p="http://schemas.openxmlformats.org/presentationml/2006/main">
   <p:cSld>
@@ -1665,7 +1393,7 @@
           <a:p>
             <a:r>
               <a:rPr lang="en-US" dirty="0"/>
-              <a:t>This is the differentiator: characterising the infrastructure and designing to it, rather than assuming bandwidth and reporting failures as errors.</a:t>
+              <a:t>This is the differentiator: the sandbox changed protocol, host and access model three times during the build, and only the adapter layer changed with it. That is the property a 26-department rollout needs. Credentials never enter the registry: injected at stream-open, redacted everywhere else.</a:t>
             </a:r>
             <a:endParaRPr lang="en-US" dirty="0"/>
           </a:p>
@@ -2585,7 +2313,7 @@
                 <a:ea typeface="Cambria" pitchFamily="34" charset="-122"/>
                 <a:cs typeface="Cambria" pitchFamily="34" charset="-120"/>
               </a:rPr>
-              <a:t>59</a:t>
+              <a:t>68</a:t>
             </a:r>
             <a:endParaRPr lang="en-US" sz="2500" dirty="0"/>
           </a:p>
@@ -7162,7 +6890,7 @@
                 <a:ea typeface="Calibri" pitchFamily="34" charset="-122"/>
                 <a:cs typeface="Calibri" pitchFamily="34" charset="-120"/>
               </a:rPr>
-              <a:t>http-progressive · RTSP over TCP · file · HLS/ONVIF-ready · adaptive ingest scheduler · shared MJPEG relay</a:t>
+              <a:t>RTSP over TCP (credentialed) · cookie-gated HLS · http-progressive · file · ONVIF-ready · adaptive ingest scheduler · shared MJPEG relay</a:t>
             </a:r>
             <a:endParaRPr lang="en-US" sz="1150" dirty="0"/>
           </a:p>
@@ -10463,7 +10191,7 @@
                 <a:ea typeface="Cambria" pitchFamily="34" charset="-122"/>
                 <a:cs typeface="Cambria" pitchFamily="34" charset="-120"/>
               </a:rPr>
-              <a:t>We measured the network before designing for it</a:t>
+              <a:t>The sandbox moved three times. The platform did not.</a:t>
             </a:r>
             <a:endParaRPr lang="en-US" sz="3200" dirty="0"/>
           </a:p>
@@ -10478,7 +10206,7 @@
         <p:spPr>
           <a:xfrm>
             <a:off x="548640" y="1481328"/>
-            <a:ext cx="11064240" cy="566928"/>
+            <a:ext cx="11064240" cy="658368"/>
           </a:xfrm>
           <a:prstGeom prst="rect">
             <a:avLst/>
@@ -10505,7 +10233,7 @@
                 <a:ea typeface="Calibri" pitchFamily="34" charset="-122"/>
                 <a:cs typeface="Calibri" pitchFamily="34" charset="-120"/>
               </a:rPr>
-              <a:t>The sandbox portal rations delivery per client IP. Independent probes at 10 and 20 concurrent connections returned the same aggregate — so opening more streams only thins each one. This is the constraint a statewide rollout actually faces.</a:t>
+              <a:t>Integration is where statewide rollouts fail: every department is a different vendor, protocol and access model. The hackathon sandbox rehearsed exactly that by changing under us — and SUTRA's adapter + discovery layer absorbed every change without touching registry, analytics, alerting or UI.</a:t>
             </a:r>
             <a:endParaRPr lang="en-US" sz="1300" dirty="0"/>
           </a:p>
@@ -10513,17 +10241,856 @@
       </p:sp>
       <p:graphicFrame>
         <p:nvGraphicFramePr>
-          <p:cNvPr id="5" name="Chart 0" descr=""/>
-          <p:cNvGraphicFramePr/>
-          <p:nvPr/>
+          <p:cNvPr id="9" name="Table 0"/>
+          <p:cNvGraphicFramePr>
+            <a:graphicFrameLocks noGrp="1"/>
+          </p:cNvGraphicFramePr>
+          <p:nvPr>
+            <p:extLst>
+              <p:ext uri="{D42A27DB-BD31-4B8C-83A1-F6EECF244321}">
+                <p14:modId xmlns:p14="http://schemas.microsoft.com/office/powerpoint/2010/main" val="1579011935"/>
+              </p:ext>
+            </p:extLst>
+          </p:nvPr>
         </p:nvGraphicFramePr>
         <p:xfrm>
-          <a:off x="548640" y="2240280"/>
-          <a:ext cx="5486400" cy="3200400"/>
+          <a:off x="548640" y="2286000"/>
+          <a:ext cx="5760720" cy="914400"/>
         </p:xfrm>
-        <a:graphic xmlns:a="http://schemas.openxmlformats.org/drawingml/2006/main">
-          <a:graphicData uri="http://schemas.openxmlformats.org/drawingml/2006/chart">
-            <c:chart xmlns:c="http://schemas.openxmlformats.org/drawingml/2006/chart" r:id="rId1"/>
+        <a:graphic>
+          <a:graphicData uri="http://schemas.openxmlformats.org/drawingml/2006/table">
+            <a:tbl>
+              <a:tblPr/>
+              <a:tblGrid>
+                <a:gridCol w="1417320"/>
+                <a:gridCol w="2331720"/>
+                <a:gridCol w="2011680"/>
+              </a:tblGrid>
+              <a:tr h="310896">
+                <a:tc>
+                  <a:txBody>
+                    <a:bodyPr/>
+                    <a:lstStyle/>
+                    <a:p>
+                      <a:pPr indent="0" marL="0">
+                        <a:buNone/>
+                      </a:pPr>
+                      <a:r>
+                        <a:rPr lang="en-US" sz="1050" b="1" dirty="0">
+                          <a:solidFill>
+                            <a:srgbClr val="FFFFFF"/>
+                          </a:solidFill>
+                          <a:latin typeface="Calibri" pitchFamily="34" charset="0"/>
+                          <a:ea typeface="Calibri" pitchFamily="34" charset="-122"/>
+                          <a:cs typeface="Calibri" pitchFamily="34" charset="-120"/>
+                        </a:rPr>
+                        <a:t>Portal generation</a:t>
+                      </a:r>
+                      <a:endParaRPr lang="en-US" sz="1050" dirty="0">
+                        <a:latin typeface="Calibri" charset="0"/>
+                        <a:ea typeface="Calibri" charset="0"/>
+                        <a:cs typeface="Calibri" charset="0"/>
+                      </a:endParaRPr>
+                    </a:p>
+                  </a:txBody>
+                  <a:tcPr marL="54864" marR="54864" marT="54864" marB="54864" anchor="t">
+                    <a:lnL w="9525" cap="flat" cmpd="sng" algn="ctr">
+                      <a:solidFill>
+                        <a:srgbClr val="24405E"/>
+                      </a:solidFill>
+                      <a:prstDash val="solid"/>
+                      <a:round/>
+                      <a:headEnd type="none" w="med" len="med"/>
+                      <a:tailEnd type="none" w="med" len="med"/>
+                    </a:lnL>
+                    <a:lnR w="9525" cap="flat" cmpd="sng" algn="ctr">
+                      <a:solidFill>
+                        <a:srgbClr val="24405E"/>
+                      </a:solidFill>
+                      <a:prstDash val="solid"/>
+                      <a:round/>
+                      <a:headEnd type="none" w="med" len="med"/>
+                      <a:tailEnd type="none" w="med" len="med"/>
+                    </a:lnR>
+                    <a:lnT w="9525" cap="flat" cmpd="sng" algn="ctr">
+                      <a:solidFill>
+                        <a:srgbClr val="24405E"/>
+                      </a:solidFill>
+                      <a:prstDash val="solid"/>
+                      <a:round/>
+                      <a:headEnd type="none" w="med" len="med"/>
+                      <a:tailEnd type="none" w="med" len="med"/>
+                    </a:lnT>
+                    <a:lnB w="9525" cap="flat" cmpd="sng" algn="ctr">
+                      <a:solidFill>
+                        <a:srgbClr val="24405E"/>
+                      </a:solidFill>
+                      <a:prstDash val="solid"/>
+                      <a:round/>
+                      <a:headEnd type="none" w="med" len="med"/>
+                      <a:tailEnd type="none" w="med" len="med"/>
+                    </a:lnB>
+                    <a:solidFill>
+                      <a:srgbClr val="24405E"/>
+                    </a:solidFill>
+                  </a:tcPr>
+                </a:tc>
+                <a:tc>
+                  <a:txBody>
+                    <a:bodyPr/>
+                    <a:lstStyle/>
+                    <a:p>
+                      <a:pPr indent="0" marL="0">
+                        <a:buNone/>
+                      </a:pPr>
+                      <a:r>
+                        <a:rPr lang="en-US" sz="1050" b="1" dirty="0">
+                          <a:solidFill>
+                            <a:srgbClr val="FFFFFF"/>
+                          </a:solidFill>
+                          <a:latin typeface="Calibri" pitchFamily="34" charset="0"/>
+                          <a:ea typeface="Calibri" pitchFamily="34" charset="-122"/>
+                          <a:cs typeface="Calibri" pitchFamily="34" charset="-120"/>
+                        </a:rPr>
+                        <a:t>What the source looked like</a:t>
+                      </a:r>
+                      <a:endParaRPr lang="en-US" sz="1050" dirty="0">
+                        <a:latin typeface="Calibri" charset="0"/>
+                        <a:ea typeface="Calibri" charset="0"/>
+                        <a:cs typeface="Calibri" charset="0"/>
+                      </a:endParaRPr>
+                    </a:p>
+                  </a:txBody>
+                  <a:tcPr marL="54864" marR="54864" marT="54864" marB="54864" anchor="t">
+                    <a:lnL w="9525" cap="flat" cmpd="sng" algn="ctr">
+                      <a:solidFill>
+                        <a:srgbClr val="24405E"/>
+                      </a:solidFill>
+                      <a:prstDash val="solid"/>
+                      <a:round/>
+                      <a:headEnd type="none" w="med" len="med"/>
+                      <a:tailEnd type="none" w="med" len="med"/>
+                    </a:lnL>
+                    <a:lnR w="9525" cap="flat" cmpd="sng" algn="ctr">
+                      <a:solidFill>
+                        <a:srgbClr val="24405E"/>
+                      </a:solidFill>
+                      <a:prstDash val="solid"/>
+                      <a:round/>
+                      <a:headEnd type="none" w="med" len="med"/>
+                      <a:tailEnd type="none" w="med" len="med"/>
+                    </a:lnR>
+                    <a:lnT w="9525" cap="flat" cmpd="sng" algn="ctr">
+                      <a:solidFill>
+                        <a:srgbClr val="24405E"/>
+                      </a:solidFill>
+                      <a:prstDash val="solid"/>
+                      <a:round/>
+                      <a:headEnd type="none" w="med" len="med"/>
+                      <a:tailEnd type="none" w="med" len="med"/>
+                    </a:lnT>
+                    <a:lnB w="9525" cap="flat" cmpd="sng" algn="ctr">
+                      <a:solidFill>
+                        <a:srgbClr val="24405E"/>
+                      </a:solidFill>
+                      <a:prstDash val="solid"/>
+                      <a:round/>
+                      <a:headEnd type="none" w="med" len="med"/>
+                      <a:tailEnd type="none" w="med" len="med"/>
+                    </a:lnB>
+                    <a:solidFill>
+                      <a:srgbClr val="24405E"/>
+                    </a:solidFill>
+                  </a:tcPr>
+                </a:tc>
+                <a:tc>
+                  <a:txBody>
+                    <a:bodyPr/>
+                    <a:lstStyle/>
+                    <a:p>
+                      <a:pPr indent="0" marL="0">
+                        <a:buNone/>
+                      </a:pPr>
+                      <a:r>
+                        <a:rPr lang="en-US" sz="1050" b="1" dirty="0">
+                          <a:solidFill>
+                            <a:srgbClr val="FFFFFF"/>
+                          </a:solidFill>
+                          <a:latin typeface="Calibri" pitchFamily="34" charset="0"/>
+                          <a:ea typeface="Calibri" pitchFamily="34" charset="-122"/>
+                          <a:cs typeface="Calibri" pitchFamily="34" charset="-120"/>
+                        </a:rPr>
+                        <a:t>What SUTRA changed</a:t>
+                      </a:r>
+                      <a:endParaRPr lang="en-US" sz="1050" dirty="0">
+                        <a:latin typeface="Calibri" charset="0"/>
+                        <a:ea typeface="Calibri" charset="0"/>
+                        <a:cs typeface="Calibri" charset="0"/>
+                      </a:endParaRPr>
+                    </a:p>
+                  </a:txBody>
+                  <a:tcPr marL="54864" marR="54864" marT="54864" marB="54864" anchor="t">
+                    <a:lnL w="9525" cap="flat" cmpd="sng" algn="ctr">
+                      <a:solidFill>
+                        <a:srgbClr val="24405E"/>
+                      </a:solidFill>
+                      <a:prstDash val="solid"/>
+                      <a:round/>
+                      <a:headEnd type="none" w="med" len="med"/>
+                      <a:tailEnd type="none" w="med" len="med"/>
+                    </a:lnL>
+                    <a:lnR w="9525" cap="flat" cmpd="sng" algn="ctr">
+                      <a:solidFill>
+                        <a:srgbClr val="24405E"/>
+                      </a:solidFill>
+                      <a:prstDash val="solid"/>
+                      <a:round/>
+                      <a:headEnd type="none" w="med" len="med"/>
+                      <a:tailEnd type="none" w="med" len="med"/>
+                    </a:lnR>
+                    <a:lnT w="9525" cap="flat" cmpd="sng" algn="ctr">
+                      <a:solidFill>
+                        <a:srgbClr val="24405E"/>
+                      </a:solidFill>
+                      <a:prstDash val="solid"/>
+                      <a:round/>
+                      <a:headEnd type="none" w="med" len="med"/>
+                      <a:tailEnd type="none" w="med" len="med"/>
+                    </a:lnT>
+                    <a:lnB w="9525" cap="flat" cmpd="sng" algn="ctr">
+                      <a:solidFill>
+                        <a:srgbClr val="24405E"/>
+                      </a:solidFill>
+                      <a:prstDash val="solid"/>
+                      <a:round/>
+                      <a:headEnd type="none" w="med" len="med"/>
+                      <a:tailEnd type="none" w="med" len="med"/>
+                    </a:lnB>
+                    <a:solidFill>
+                      <a:srgbClr val="24405E"/>
+                    </a:solidFill>
+                  </a:tcPr>
+                </a:tc>
+              </a:tr>
+              <a:tr h="713232">
+                <a:tc>
+                  <a:txBody>
+                    <a:bodyPr/>
+                    <a:lstStyle/>
+                    <a:p>
+                      <a:pPr indent="0" marL="0">
+                        <a:buNone/>
+                      </a:pPr>
+                      <a:r>
+                        <a:rPr lang="en-US" sz="1000" dirty="0">
+                          <a:solidFill>
+                            <a:srgbClr val="CBD8E8"/>
+                          </a:solidFill>
+                          <a:latin typeface="Calibri" pitchFamily="34" charset="0"/>
+                          <a:ea typeface="Calibri" pitchFamily="34" charset="-122"/>
+                          <a:cs typeface="Calibri" pitchFamily="34" charset="-120"/>
+                        </a:rPr>
+                        <a:t>Aug · live.sentinelgujarat.in</a:t>
+                      </a:r>
+                      <a:endParaRPr lang="en-US" sz="1000" dirty="0">
+                        <a:latin typeface="Calibri" charset="0"/>
+                        <a:ea typeface="Calibri" charset="0"/>
+                        <a:cs typeface="Calibri" charset="0"/>
+                      </a:endParaRPr>
+                    </a:p>
+                  </a:txBody>
+                  <a:tcPr marL="54864" marR="54864" marT="54864" marB="54864" anchor="t">
+                    <a:lnL w="9525" cap="flat" cmpd="sng" algn="ctr">
+                      <a:solidFill>
+                        <a:srgbClr val="24405E"/>
+                      </a:solidFill>
+                      <a:prstDash val="solid"/>
+                      <a:round/>
+                      <a:headEnd type="none" w="med" len="med"/>
+                      <a:tailEnd type="none" w="med" len="med"/>
+                    </a:lnL>
+                    <a:lnR w="9525" cap="flat" cmpd="sng" algn="ctr">
+                      <a:solidFill>
+                        <a:srgbClr val="24405E"/>
+                      </a:solidFill>
+                      <a:prstDash val="solid"/>
+                      <a:round/>
+                      <a:headEnd type="none" w="med" len="med"/>
+                      <a:tailEnd type="none" w="med" len="med"/>
+                    </a:lnR>
+                    <a:lnT w="9525" cap="flat" cmpd="sng" algn="ctr">
+                      <a:solidFill>
+                        <a:srgbClr val="24405E"/>
+                      </a:solidFill>
+                      <a:prstDash val="solid"/>
+                      <a:round/>
+                      <a:headEnd type="none" w="med" len="med"/>
+                      <a:tailEnd type="none" w="med" len="med"/>
+                    </a:lnT>
+                    <a:lnB w="9525" cap="flat" cmpd="sng" algn="ctr">
+                      <a:solidFill>
+                        <a:srgbClr val="24405E"/>
+                      </a:solidFill>
+                      <a:prstDash val="solid"/>
+                      <a:round/>
+                      <a:headEnd type="none" w="med" len="med"/>
+                      <a:tailEnd type="none" w="med" len="med"/>
+                    </a:lnB>
+                    <a:solidFill>
+                      <a:srgbClr val="0E1A2B"/>
+                    </a:solidFill>
+                  </a:tcPr>
+                </a:tc>
+                <a:tc>
+                  <a:txBody>
+                    <a:bodyPr/>
+                    <a:lstStyle/>
+                    <a:p>
+                      <a:pPr indent="0" marL="0">
+                        <a:buNone/>
+                      </a:pPr>
+                      <a:r>
+                        <a:rPr lang="en-US" sz="1000" dirty="0">
+                          <a:solidFill>
+                            <a:srgbClr val="CBD8E8"/>
+                          </a:solidFill>
+                          <a:latin typeface="Calibri" pitchFamily="34" charset="0"/>
+                          <a:ea typeface="Calibri" pitchFamily="34" charset="-122"/>
+                          <a:cs typeface="Calibri" pitchFamily="34" charset="-120"/>
+                        </a:rPr>
+                        <a:t>Progressive MP4/MKV/AVI chunks, ~5 Mb/s per client IP, 48 s to first frame</a:t>
+                      </a:r>
+                      <a:endParaRPr lang="en-US" sz="1000" dirty="0">
+                        <a:latin typeface="Calibri" charset="0"/>
+                        <a:ea typeface="Calibri" charset="0"/>
+                        <a:cs typeface="Calibri" charset="0"/>
+                      </a:endParaRPr>
+                    </a:p>
+                  </a:txBody>
+                  <a:tcPr marL="54864" marR="54864" marT="54864" marB="54864" anchor="t">
+                    <a:lnL w="9525" cap="flat" cmpd="sng" algn="ctr">
+                      <a:solidFill>
+                        <a:srgbClr val="24405E"/>
+                      </a:solidFill>
+                      <a:prstDash val="solid"/>
+                      <a:round/>
+                      <a:headEnd type="none" w="med" len="med"/>
+                      <a:tailEnd type="none" w="med" len="med"/>
+                    </a:lnL>
+                    <a:lnR w="9525" cap="flat" cmpd="sng" algn="ctr">
+                      <a:solidFill>
+                        <a:srgbClr val="24405E"/>
+                      </a:solidFill>
+                      <a:prstDash val="solid"/>
+                      <a:round/>
+                      <a:headEnd type="none" w="med" len="med"/>
+                      <a:tailEnd type="none" w="med" len="med"/>
+                    </a:lnR>
+                    <a:lnT w="9525" cap="flat" cmpd="sng" algn="ctr">
+                      <a:solidFill>
+                        <a:srgbClr val="24405E"/>
+                      </a:solidFill>
+                      <a:prstDash val="solid"/>
+                      <a:round/>
+                      <a:headEnd type="none" w="med" len="med"/>
+                      <a:tailEnd type="none" w="med" len="med"/>
+                    </a:lnT>
+                    <a:lnB w="9525" cap="flat" cmpd="sng" algn="ctr">
+                      <a:solidFill>
+                        <a:srgbClr val="24405E"/>
+                      </a:solidFill>
+                      <a:prstDash val="solid"/>
+                      <a:round/>
+                      <a:headEnd type="none" w="med" len="med"/>
+                      <a:tailEnd type="none" w="med" len="med"/>
+                    </a:lnB>
+                    <a:solidFill>
+                      <a:srgbClr val="0E1A2B"/>
+                    </a:solidFill>
+                  </a:tcPr>
+                </a:tc>
+                <a:tc>
+                  <a:txBody>
+                    <a:bodyPr/>
+                    <a:lstStyle/>
+                    <a:p>
+                      <a:pPr indent="0" marL="0">
+                        <a:buNone/>
+                      </a:pPr>
+                      <a:r>
+                        <a:rPr lang="en-US" sz="1000" dirty="0">
+                          <a:solidFill>
+                            <a:srgbClr val="CBD8E8"/>
+                          </a:solidFill>
+                          <a:latin typeface="Calibri" pitchFamily="34" charset="0"/>
+                          <a:ea typeface="Calibri" pitchFamily="34" charset="-122"/>
+                          <a:cs typeface="Calibri" pitchFamily="34" charset="-120"/>
+                        </a:rPr>
+                        <a:t>Adaptive scheduler sized to the source; http-progressive adapter</a:t>
+                      </a:r>
+                      <a:endParaRPr lang="en-US" sz="1000" dirty="0">
+                        <a:latin typeface="Calibri" charset="0"/>
+                        <a:ea typeface="Calibri" charset="0"/>
+                        <a:cs typeface="Calibri" charset="0"/>
+                      </a:endParaRPr>
+                    </a:p>
+                  </a:txBody>
+                  <a:tcPr marL="54864" marR="54864" marT="54864" marB="54864" anchor="t">
+                    <a:lnL w="9525" cap="flat" cmpd="sng" algn="ctr">
+                      <a:solidFill>
+                        <a:srgbClr val="24405E"/>
+                      </a:solidFill>
+                      <a:prstDash val="solid"/>
+                      <a:round/>
+                      <a:headEnd type="none" w="med" len="med"/>
+                      <a:tailEnd type="none" w="med" len="med"/>
+                    </a:lnL>
+                    <a:lnR w="9525" cap="flat" cmpd="sng" algn="ctr">
+                      <a:solidFill>
+                        <a:srgbClr val="24405E"/>
+                      </a:solidFill>
+                      <a:prstDash val="solid"/>
+                      <a:round/>
+                      <a:headEnd type="none" w="med" len="med"/>
+                      <a:tailEnd type="none" w="med" len="med"/>
+                    </a:lnR>
+                    <a:lnT w="9525" cap="flat" cmpd="sng" algn="ctr">
+                      <a:solidFill>
+                        <a:srgbClr val="24405E"/>
+                      </a:solidFill>
+                      <a:prstDash val="solid"/>
+                      <a:round/>
+                      <a:headEnd type="none" w="med" len="med"/>
+                      <a:tailEnd type="none" w="med" len="med"/>
+                    </a:lnT>
+                    <a:lnB w="9525" cap="flat" cmpd="sng" algn="ctr">
+                      <a:solidFill>
+                        <a:srgbClr val="24405E"/>
+                      </a:solidFill>
+                      <a:prstDash val="solid"/>
+                      <a:round/>
+                      <a:headEnd type="none" w="med" len="med"/>
+                      <a:tailEnd type="none" w="med" len="med"/>
+                    </a:lnB>
+                    <a:solidFill>
+                      <a:srgbClr val="0E1A2B"/>
+                    </a:solidFill>
+                  </a:tcPr>
+                </a:tc>
+              </a:tr>
+              <a:tr h="548640">
+                <a:tc>
+                  <a:txBody>
+                    <a:bodyPr/>
+                    <a:lstStyle/>
+                    <a:p>
+                      <a:pPr indent="0" marL="0">
+                        <a:buNone/>
+                      </a:pPr>
+                      <a:r>
+                        <a:rPr lang="en-US" sz="1000" dirty="0">
+                          <a:solidFill>
+                            <a:srgbClr val="CBD8E8"/>
+                          </a:solidFill>
+                          <a:latin typeface="Calibri" pitchFamily="34" charset="0"/>
+                          <a:ea typeface="Calibri" pitchFamily="34" charset="-122"/>
+                          <a:cs typeface="Calibri" pitchFamily="34" charset="-120"/>
+                        </a:rPr>
+                        <a:t>Aug · live.corp8.cloud</a:t>
+                      </a:r>
+                      <a:endParaRPr lang="en-US" sz="1000" dirty="0">
+                        <a:latin typeface="Calibri" charset="0"/>
+                        <a:ea typeface="Calibri" charset="0"/>
+                        <a:cs typeface="Calibri" charset="0"/>
+                      </a:endParaRPr>
+                    </a:p>
+                  </a:txBody>
+                  <a:tcPr marL="54864" marR="54864" marT="54864" marB="54864" anchor="t">
+                    <a:lnL w="9525" cap="flat" cmpd="sng" algn="ctr">
+                      <a:solidFill>
+                        <a:srgbClr val="24405E"/>
+                      </a:solidFill>
+                      <a:prstDash val="solid"/>
+                      <a:round/>
+                      <a:headEnd type="none" w="med" len="med"/>
+                      <a:tailEnd type="none" w="med" len="med"/>
+                    </a:lnL>
+                    <a:lnR w="9525" cap="flat" cmpd="sng" algn="ctr">
+                      <a:solidFill>
+                        <a:srgbClr val="24405E"/>
+                      </a:solidFill>
+                      <a:prstDash val="solid"/>
+                      <a:round/>
+                      <a:headEnd type="none" w="med" len="med"/>
+                      <a:tailEnd type="none" w="med" len="med"/>
+                    </a:lnR>
+                    <a:lnT w="9525" cap="flat" cmpd="sng" algn="ctr">
+                      <a:solidFill>
+                        <a:srgbClr val="24405E"/>
+                      </a:solidFill>
+                      <a:prstDash val="solid"/>
+                      <a:round/>
+                      <a:headEnd type="none" w="med" len="med"/>
+                      <a:tailEnd type="none" w="med" len="med"/>
+                    </a:lnT>
+                    <a:lnB w="9525" cap="flat" cmpd="sng" algn="ctr">
+                      <a:solidFill>
+                        <a:srgbClr val="24405E"/>
+                      </a:solidFill>
+                      <a:prstDash val="solid"/>
+                      <a:round/>
+                      <a:headEnd type="none" w="med" len="med"/>
+                      <a:tailEnd type="none" w="med" len="med"/>
+                    </a:lnB>
+                    <a:solidFill>
+                      <a:srgbClr val="0E1A2B"/>
+                    </a:solidFill>
+                  </a:tcPr>
+                </a:tc>
+                <a:tc>
+                  <a:txBody>
+                    <a:bodyPr/>
+                    <a:lstStyle/>
+                    <a:p>
+                      <a:pPr indent="0" marL="0">
+                        <a:buNone/>
+                      </a:pPr>
+                      <a:r>
+                        <a:rPr lang="en-US" sz="1000" dirty="0">
+                          <a:solidFill>
+                            <a:srgbClr val="CBD8E8"/>
+                          </a:solidFill>
+                          <a:latin typeface="Calibri" pitchFamily="34" charset="0"/>
+                          <a:ea typeface="Calibri" pitchFamily="34" charset="-122"/>
+                          <a:cs typeface="Calibri" pitchFamily="34" charset="-120"/>
+                        </a:rPr>
+                        <a:t>Same API, new host, wider camera set</a:t>
+                      </a:r>
+                      <a:endParaRPr lang="en-US" sz="1000" dirty="0">
+                        <a:latin typeface="Calibri" charset="0"/>
+                        <a:ea typeface="Calibri" charset="0"/>
+                        <a:cs typeface="Calibri" charset="0"/>
+                      </a:endParaRPr>
+                    </a:p>
+                  </a:txBody>
+                  <a:tcPr marL="54864" marR="54864" marT="54864" marB="54864" anchor="t">
+                    <a:lnL w="9525" cap="flat" cmpd="sng" algn="ctr">
+                      <a:solidFill>
+                        <a:srgbClr val="24405E"/>
+                      </a:solidFill>
+                      <a:prstDash val="solid"/>
+                      <a:round/>
+                      <a:headEnd type="none" w="med" len="med"/>
+                      <a:tailEnd type="none" w="med" len="med"/>
+                    </a:lnL>
+                    <a:lnR w="9525" cap="flat" cmpd="sng" algn="ctr">
+                      <a:solidFill>
+                        <a:srgbClr val="24405E"/>
+                      </a:solidFill>
+                      <a:prstDash val="solid"/>
+                      <a:round/>
+                      <a:headEnd type="none" w="med" len="med"/>
+                      <a:tailEnd type="none" w="med" len="med"/>
+                    </a:lnR>
+                    <a:lnT w="9525" cap="flat" cmpd="sng" algn="ctr">
+                      <a:solidFill>
+                        <a:srgbClr val="24405E"/>
+                      </a:solidFill>
+                      <a:prstDash val="solid"/>
+                      <a:round/>
+                      <a:headEnd type="none" w="med" len="med"/>
+                      <a:tailEnd type="none" w="med" len="med"/>
+                    </a:lnT>
+                    <a:lnB w="9525" cap="flat" cmpd="sng" algn="ctr">
+                      <a:solidFill>
+                        <a:srgbClr val="24405E"/>
+                      </a:solidFill>
+                      <a:prstDash val="solid"/>
+                      <a:round/>
+                      <a:headEnd type="none" w="med" len="med"/>
+                      <a:tailEnd type="none" w="med" len="med"/>
+                    </a:lnB>
+                    <a:solidFill>
+                      <a:srgbClr val="0E1A2B"/>
+                    </a:solidFill>
+                  </a:tcPr>
+                </a:tc>
+                <a:tc>
+                  <a:txBody>
+                    <a:bodyPr/>
+                    <a:lstStyle/>
+                    <a:p>
+                      <a:pPr indent="0" marL="0">
+                        <a:buNone/>
+                      </a:pPr>
+                      <a:r>
+                        <a:rPr lang="en-US" sz="1000" dirty="0">
+                          <a:solidFill>
+                            <a:srgbClr val="CBD8E8"/>
+                          </a:solidFill>
+                          <a:latin typeface="Calibri" pitchFamily="34" charset="0"/>
+                          <a:ea typeface="Calibri" pitchFamily="34" charset="-122"/>
+                          <a:cs typeface="Calibri" pitchFamily="34" charset="-120"/>
+                        </a:rPr>
+                        <a:t>Discovery keyed on stable ids — rows updated in place</a:t>
+                      </a:r>
+                      <a:endParaRPr lang="en-US" sz="1000" dirty="0">
+                        <a:latin typeface="Calibri" charset="0"/>
+                        <a:ea typeface="Calibri" charset="0"/>
+                        <a:cs typeface="Calibri" charset="0"/>
+                      </a:endParaRPr>
+                    </a:p>
+                  </a:txBody>
+                  <a:tcPr marL="54864" marR="54864" marT="54864" marB="54864" anchor="t">
+                    <a:lnL w="9525" cap="flat" cmpd="sng" algn="ctr">
+                      <a:solidFill>
+                        <a:srgbClr val="24405E"/>
+                      </a:solidFill>
+                      <a:prstDash val="solid"/>
+                      <a:round/>
+                      <a:headEnd type="none" w="med" len="med"/>
+                      <a:tailEnd type="none" w="med" len="med"/>
+                    </a:lnL>
+                    <a:lnR w="9525" cap="flat" cmpd="sng" algn="ctr">
+                      <a:solidFill>
+                        <a:srgbClr val="24405E"/>
+                      </a:solidFill>
+                      <a:prstDash val="solid"/>
+                      <a:round/>
+                      <a:headEnd type="none" w="med" len="med"/>
+                      <a:tailEnd type="none" w="med" len="med"/>
+                    </a:lnR>
+                    <a:lnT w="9525" cap="flat" cmpd="sng" algn="ctr">
+                      <a:solidFill>
+                        <a:srgbClr val="24405E"/>
+                      </a:solidFill>
+                      <a:prstDash val="solid"/>
+                      <a:round/>
+                      <a:headEnd type="none" w="med" len="med"/>
+                      <a:tailEnd type="none" w="med" len="med"/>
+                    </a:lnT>
+                    <a:lnB w="9525" cap="flat" cmpd="sng" algn="ctr">
+                      <a:solidFill>
+                        <a:srgbClr val="24405E"/>
+                      </a:solidFill>
+                      <a:prstDash val="solid"/>
+                      <a:round/>
+                      <a:headEnd type="none" w="med" len="med"/>
+                      <a:tailEnd type="none" w="med" len="med"/>
+                    </a:lnB>
+                    <a:solidFill>
+                      <a:srgbClr val="0E1A2B"/>
+                    </a:solidFill>
+                  </a:tcPr>
+                </a:tc>
+              </a:tr>
+              <a:tr h="822960">
+                <a:tc>
+                  <a:txBody>
+                    <a:bodyPr/>
+                    <a:lstStyle/>
+                    <a:p>
+                      <a:pPr indent="0" marL="0">
+                        <a:buNone/>
+                      </a:pPr>
+                      <a:r>
+                        <a:rPr lang="en-US" sz="1000" dirty="0">
+                          <a:solidFill>
+                            <a:srgbClr val="CBD8E8"/>
+                          </a:solidFill>
+                          <a:latin typeface="Calibri" pitchFamily="34" charset="0"/>
+                          <a:ea typeface="Calibri" pitchFamily="34" charset="-122"/>
+                          <a:cs typeface="Calibri" pitchFamily="34" charset="-120"/>
+                        </a:rPr>
+                        <a:t>Sep · cctv.corp8.cloud</a:t>
+                      </a:r>
+                      <a:endParaRPr lang="en-US" sz="1000" dirty="0">
+                        <a:latin typeface="Calibri" charset="0"/>
+                        <a:ea typeface="Calibri" charset="0"/>
+                        <a:cs typeface="Calibri" charset="0"/>
+                      </a:endParaRPr>
+                    </a:p>
+                  </a:txBody>
+                  <a:tcPr marL="54864" marR="54864" marT="54864" marB="54864" anchor="t">
+                    <a:lnL w="9525" cap="flat" cmpd="sng" algn="ctr">
+                      <a:solidFill>
+                        <a:srgbClr val="24405E"/>
+                      </a:solidFill>
+                      <a:prstDash val="solid"/>
+                      <a:round/>
+                      <a:headEnd type="none" w="med" len="med"/>
+                      <a:tailEnd type="none" w="med" len="med"/>
+                    </a:lnL>
+                    <a:lnR w="9525" cap="flat" cmpd="sng" algn="ctr">
+                      <a:solidFill>
+                        <a:srgbClr val="24405E"/>
+                      </a:solidFill>
+                      <a:prstDash val="solid"/>
+                      <a:round/>
+                      <a:headEnd type="none" w="med" len="med"/>
+                      <a:tailEnd type="none" w="med" len="med"/>
+                    </a:lnR>
+                    <a:lnT w="9525" cap="flat" cmpd="sng" algn="ctr">
+                      <a:solidFill>
+                        <a:srgbClr val="24405E"/>
+                      </a:solidFill>
+                      <a:prstDash val="solid"/>
+                      <a:round/>
+                      <a:headEnd type="none" w="med" len="med"/>
+                      <a:tailEnd type="none" w="med" len="med"/>
+                    </a:lnT>
+                    <a:lnB w="9525" cap="flat" cmpd="sng" algn="ctr">
+                      <a:solidFill>
+                        <a:srgbClr val="24405E"/>
+                      </a:solidFill>
+                      <a:prstDash val="solid"/>
+                      <a:round/>
+                      <a:headEnd type="none" w="med" len="med"/>
+                      <a:tailEnd type="none" w="med" len="med"/>
+                    </a:lnB>
+                    <a:solidFill>
+                      <a:srgbClr val="0E1A2B"/>
+                    </a:solidFill>
+                  </a:tcPr>
+                </a:tc>
+                <a:tc>
+                  <a:txBody>
+                    <a:bodyPr/>
+                    <a:lstStyle/>
+                    <a:p>
+                      <a:pPr indent="0" marL="0">
+                        <a:buNone/>
+                      </a:pPr>
+                      <a:r>
+                        <a:rPr lang="en-US" sz="1000" dirty="0">
+                          <a:solidFill>
+                            <a:srgbClr val="CBD8E8"/>
+                          </a:solidFill>
+                          <a:latin typeface="Calibri" pitchFamily="34" charset="0"/>
+                          <a:ea typeface="Calibri" pitchFamily="34" charset="-122"/>
+                          <a:cs typeface="Calibri" pitchFamily="34" charset="-120"/>
+                        </a:rPr>
+                        <a:t>Login-gated catalogue, credentialed RTSP (H.264 + H.265), AES-encrypted cookie HLS, looping feeds</a:t>
+                      </a:r>
+                      <a:endParaRPr lang="en-US" sz="1000" dirty="0">
+                        <a:latin typeface="Calibri" charset="0"/>
+                        <a:ea typeface="Calibri" charset="0"/>
+                        <a:cs typeface="Calibri" charset="0"/>
+                      </a:endParaRPr>
+                    </a:p>
+                  </a:txBody>
+                  <a:tcPr marL="54864" marR="54864" marT="54864" marB="54864" anchor="t">
+                    <a:lnL w="9525" cap="flat" cmpd="sng" algn="ctr">
+                      <a:solidFill>
+                        <a:srgbClr val="24405E"/>
+                      </a:solidFill>
+                      <a:prstDash val="solid"/>
+                      <a:round/>
+                      <a:headEnd type="none" w="med" len="med"/>
+                      <a:tailEnd type="none" w="med" len="med"/>
+                    </a:lnL>
+                    <a:lnR w="9525" cap="flat" cmpd="sng" algn="ctr">
+                      <a:solidFill>
+                        <a:srgbClr val="24405E"/>
+                      </a:solidFill>
+                      <a:prstDash val="solid"/>
+                      <a:round/>
+                      <a:headEnd type="none" w="med" len="med"/>
+                      <a:tailEnd type="none" w="med" len="med"/>
+                    </a:lnR>
+                    <a:lnT w="9525" cap="flat" cmpd="sng" algn="ctr">
+                      <a:solidFill>
+                        <a:srgbClr val="24405E"/>
+                      </a:solidFill>
+                      <a:prstDash val="solid"/>
+                      <a:round/>
+                      <a:headEnd type="none" w="med" len="med"/>
+                      <a:tailEnd type="none" w="med" len="med"/>
+                    </a:lnT>
+                    <a:lnB w="9525" cap="flat" cmpd="sng" algn="ctr">
+                      <a:solidFill>
+                        <a:srgbClr val="24405E"/>
+                      </a:solidFill>
+                      <a:prstDash val="solid"/>
+                      <a:round/>
+                      <a:headEnd type="none" w="med" len="med"/>
+                      <a:tailEnd type="none" w="med" len="med"/>
+                    </a:lnB>
+                    <a:solidFill>
+                      <a:srgbClr val="0E1A2B"/>
+                    </a:solidFill>
+                  </a:tcPr>
+                </a:tc>
+                <a:tc>
+                  <a:txBody>
+                    <a:bodyPr/>
+                    <a:lstStyle/>
+                    <a:p>
+                      <a:pPr indent="0" marL="0">
+                        <a:buNone/>
+                      </a:pPr>
+                      <a:r>
+                        <a:rPr lang="en-US" sz="1000" dirty="0">
+                          <a:solidFill>
+                            <a:srgbClr val="CBD8E8"/>
+                          </a:solidFill>
+                          <a:latin typeface="Calibri" pitchFamily="34" charset="0"/>
+                          <a:ea typeface="Calibri" pitchFamily="34" charset="-122"/>
+                          <a:cs typeface="Calibri" pitchFamily="34" charset="-120"/>
+                        </a:rPr>
+                        <a:t>Portal session module, RTSP + HLS adapters, PTS-safe sampling, credential redaction</a:t>
+                      </a:r>
+                      <a:endParaRPr lang="en-US" sz="1000" dirty="0">
+                        <a:latin typeface="Calibri" charset="0"/>
+                        <a:ea typeface="Calibri" charset="0"/>
+                        <a:cs typeface="Calibri" charset="0"/>
+                      </a:endParaRPr>
+                    </a:p>
+                  </a:txBody>
+                  <a:tcPr marL="54864" marR="54864" marT="54864" marB="54864" anchor="t">
+                    <a:lnL w="9525" cap="flat" cmpd="sng" algn="ctr">
+                      <a:solidFill>
+                        <a:srgbClr val="24405E"/>
+                      </a:solidFill>
+                      <a:prstDash val="solid"/>
+                      <a:round/>
+                      <a:headEnd type="none" w="med" len="med"/>
+                      <a:tailEnd type="none" w="med" len="med"/>
+                    </a:lnL>
+                    <a:lnR w="9525" cap="flat" cmpd="sng" algn="ctr">
+                      <a:solidFill>
+                        <a:srgbClr val="24405E"/>
+                      </a:solidFill>
+                      <a:prstDash val="solid"/>
+                      <a:round/>
+                      <a:headEnd type="none" w="med" len="med"/>
+                      <a:tailEnd type="none" w="med" len="med"/>
+                    </a:lnR>
+                    <a:lnT w="9525" cap="flat" cmpd="sng" algn="ctr">
+                      <a:solidFill>
+                        <a:srgbClr val="24405E"/>
+                      </a:solidFill>
+                      <a:prstDash val="solid"/>
+                      <a:round/>
+                      <a:headEnd type="none" w="med" len="med"/>
+                      <a:tailEnd type="none" w="med" len="med"/>
+                    </a:lnT>
+                    <a:lnB w="9525" cap="flat" cmpd="sng" algn="ctr">
+                      <a:solidFill>
+                        <a:srgbClr val="24405E"/>
+                      </a:solidFill>
+                      <a:prstDash val="solid"/>
+                      <a:round/>
+                      <a:headEnd type="none" w="med" len="med"/>
+                      <a:tailEnd type="none" w="med" len="med"/>
+                    </a:lnB>
+                    <a:solidFill>
+                      <a:srgbClr val="0E1A2B"/>
+                    </a:solidFill>
+                  </a:tcPr>
+                </a:tc>
+              </a:tr>
+            </a:tbl>
           </a:graphicData>
         </a:graphic>
       </p:graphicFrame>
@@ -10535,8 +11102,8 @@
         </p:nvSpPr>
         <p:spPr>
           <a:xfrm>
-            <a:off x="6263640" y="2240280"/>
-            <a:ext cx="5349240" cy="822960"/>
+            <a:off x="6537960" y="2240280"/>
+            <a:ext cx="5074920" cy="822960"/>
           </a:xfrm>
           <a:prstGeom prst="roundRect">
             <a:avLst>
@@ -10564,7 +11131,7 @@
         </p:nvSpPr>
         <p:spPr>
           <a:xfrm>
-            <a:off x="6510528" y="2386584"/>
+            <a:off x="6784848" y="2386584"/>
             <a:ext cx="1417320" cy="384048"/>
           </a:xfrm>
           <a:prstGeom prst="rect">
@@ -10589,7 +11156,7 @@
                 <a:ea typeface="Cambria" pitchFamily="34" charset="-122"/>
                 <a:cs typeface="Cambria" pitchFamily="34" charset="-120"/>
               </a:rPr>
-              <a:t>~5 Mbps</a:t>
+              <a:t>~10 s</a:t>
             </a:r>
             <a:endParaRPr lang="en-US" sz="2100" dirty="0"/>
           </a:p>
@@ -10603,8 +11170,8 @@
         </p:nvSpPr>
         <p:spPr>
           <a:xfrm>
-            <a:off x="7973568" y="2386584"/>
-            <a:ext cx="3429000" cy="548640"/>
+            <a:off x="8247888" y="2386584"/>
+            <a:ext cx="3246120" cy="548640"/>
           </a:xfrm>
           <a:prstGeom prst="rect">
             <a:avLst/>
@@ -10631,7 +11198,7 @@
                 <a:ea typeface="Calibri" pitchFamily="34" charset="-122"/>
                 <a:cs typeface="Calibri" pitchFamily="34" charset="-120"/>
               </a:rPr>
-              <a:t>hard ceiling per client IP, regardless of connection count</a:t>
+              <a:t>to first frame on the September RTSP gateway, TCP-forced; each client gets its own copy</a:t>
             </a:r>
             <a:endParaRPr lang="en-US" sz="1150" dirty="0"/>
           </a:p>
@@ -10645,8 +11212,8 @@
         </p:nvSpPr>
         <p:spPr>
           <a:xfrm>
-            <a:off x="6263640" y="3172968"/>
-            <a:ext cx="5349240" cy="822960"/>
+            <a:off x="6537960" y="3172968"/>
+            <a:ext cx="5074920" cy="822960"/>
           </a:xfrm>
           <a:prstGeom prst="roundRect">
             <a:avLst>
@@ -10674,7 +11241,7 @@
         </p:nvSpPr>
         <p:spPr>
           <a:xfrm>
-            <a:off x="6510528" y="3319272"/>
+            <a:off x="6784848" y="3319272"/>
             <a:ext cx="1417320" cy="384048"/>
           </a:xfrm>
           <a:prstGeom prst="rect">
@@ -10699,7 +11266,7 @@
                 <a:ea typeface="Cambria" pitchFamily="34" charset="-122"/>
                 <a:cs typeface="Cambria" pitchFamily="34" charset="-120"/>
               </a:rPr>
-              <a:t>48 s</a:t>
+              <a:t>30 / 30</a:t>
             </a:r>
             <a:endParaRPr lang="en-US" sz="2100" dirty="0"/>
           </a:p>
@@ -10713,8 +11280,8 @@
         </p:nvSpPr>
         <p:spPr>
           <a:xfrm>
-            <a:off x="7973568" y="3319272"/>
-            <a:ext cx="3429000" cy="548640"/>
+            <a:off x="8247888" y="3319272"/>
+            <a:ext cx="3246120" cy="548640"/>
           </a:xfrm>
           <a:prstGeom prst="rect">
             <a:avLst/>
@@ -10741,7 +11308,7 @@
                 <a:ea typeface="Calibri" pitchFamily="34" charset="-122"/>
                 <a:cs typeface="Calibri" pitchFamily="34" charset="-120"/>
               </a:rPr>
-              <a:t>measured time to first frame — a short dwell window never yields a picture</a:t>
+              <a:t>cameras re-discovered in place after the rehost — detection history preserved</a:t>
             </a:r>
             <a:endParaRPr lang="en-US" sz="1150" dirty="0"/>
           </a:p>
@@ -10755,8 +11322,8 @@
         </p:nvSpPr>
         <p:spPr>
           <a:xfrm>
-            <a:off x="6263640" y="4105656"/>
-            <a:ext cx="5349240" cy="822960"/>
+            <a:off x="6537960" y="4105656"/>
+            <a:ext cx="5074920" cy="822960"/>
           </a:xfrm>
           <a:prstGeom prst="roundRect">
             <a:avLst>
@@ -10784,7 +11351,7 @@
         </p:nvSpPr>
         <p:spPr>
           <a:xfrm>
-            <a:off x="6510528" y="4251960"/>
+            <a:off x="6784848" y="4251960"/>
             <a:ext cx="1417320" cy="384048"/>
           </a:xfrm>
           <a:prstGeom prst="rect">
@@ -10809,7 +11376,7 @@
                 <a:ea typeface="Cambria" pitchFamily="34" charset="-122"/>
                 <a:cs typeface="Cambria" pitchFamily="34" charset="-120"/>
               </a:rPr>
-              <a:t>3–4</a:t>
+              <a:t>0</a:t>
             </a:r>
             <a:endParaRPr lang="en-US" sz="2100" dirty="0"/>
           </a:p>
@@ -10823,8 +11390,8 @@
         </p:nvSpPr>
         <p:spPr>
           <a:xfrm>
-            <a:off x="7973568" y="4251960"/>
-            <a:ext cx="3429000" cy="548640"/>
+            <a:off x="8247888" y="4251960"/>
+            <a:ext cx="3246120" cy="548640"/>
           </a:xfrm>
           <a:prstGeom prst="rect">
             <a:avLst/>
@@ -10851,7 +11418,7 @@
                 <a:ea typeface="Calibri" pitchFamily="34" charset="-122"/>
                 <a:cs typeface="Calibri" pitchFamily="34" charset="-120"/>
               </a:rPr>
-              <a:t>streams decodable in real time per IP, at ~1.5 Mbps each</a:t>
+              <a:t>changes to analytics, alerting or UI code across all three portal generations</a:t>
             </a:r>
             <a:endParaRPr lang="en-US" sz="1150" dirty="0"/>
           </a:p>
@@ -10865,8 +11432,8 @@
         </p:nvSpPr>
         <p:spPr>
           <a:xfrm>
-            <a:off x="6263640" y="5074920"/>
-            <a:ext cx="5349240" cy="1234440"/>
+            <a:off x="6537960" y="5074920"/>
+            <a:ext cx="5074920" cy="1234440"/>
           </a:xfrm>
           <a:prstGeom prst="roundRect">
             <a:avLst>
@@ -10894,8 +11461,8 @@
         </p:nvSpPr>
         <p:spPr>
           <a:xfrm>
-            <a:off x="6510528" y="5257800"/>
-            <a:ext cx="4846320" cy="274320"/>
+            <a:off x="6784848" y="5257800"/>
+            <a:ext cx="4663440" cy="274320"/>
           </a:xfrm>
           <a:prstGeom prst="rect">
             <a:avLst/>
@@ -10919,7 +11486,7 @@
                 <a:ea typeface="Cambria" pitchFamily="34" charset="-122"/>
                 <a:cs typeface="Cambria" pitchFamily="34" charset="-120"/>
               </a:rPr>
-              <a:t>So the scheduler is designed for it</a:t>
+              <a:t>So the scheduler is designed for the source</a:t>
             </a:r>
             <a:endParaRPr lang="en-US" sz="1350" dirty="0"/>
           </a:p>
@@ -10933,8 +11500,8 @@
         </p:nvSpPr>
         <p:spPr>
           <a:xfrm>
-            <a:off x="6510528" y="5559552"/>
-            <a:ext cx="4846320" cy="658368"/>
+            <a:off x="6784848" y="5559552"/>
+            <a:ext cx="4663440" cy="658368"/>
           </a:xfrm>
           <a:prstGeom prst="rect">
             <a:avLst/>
@@ -10961,7 +11528,7 @@
                 <a:ea typeface="Calibri" pitchFamily="34" charset="-122"/>
                 <a:cs typeface="Calibri" pitchFamily="34" charset="-120"/>
               </a:rPr>
-              <a:t>A concurrency budget sized to the source, 10-minute dwell rotation with least-recently-served fairness, operator pinning and alert-boost. All 30 network cameras are covered over time instead of 30 fighting for four sessions at once.</a:t>
+              <a:t>A concurrency budget sized to what the source sustains, 10-minute dwell rotation with least-recently-served fairness, operator pinning and alert-boost. All 30 network cameras are covered over time on one commodity machine.</a:t>
             </a:r>
             <a:endParaRPr lang="en-US" sz="1100" dirty="0"/>
           </a:p>

</xml_diff>

<commit_message>
Credit Hiral Kotwani as a co-author of the project
The work was designed and written by two people; the repository only ever
showed one, because everything was committed and pushed from a single account.
CONTRIBUTORS.md records the actual authorship and says plainly why the commit
history does not reflect it, rather than leaving a reader to infer solo work
from the log.

The README and submission bylines now name both, and the presentation is
regenerated from its script with both names on the title slide and in the
document author field. The deck's test count moves from 174 to 175 while it is
being rebuilt.

The participation category is deliberately left as "Category 1" without the
"Individual entry" qualifier: the registration was made as an individual and a
change has been requested from the organisers but not yet answered, so the
repository states authorship as fact and makes no claim about entry category.
</commit_message>
<xml_diff>
--- a/submission/SUTRA_Solution_Presentation.pptx
+++ b/submission/SUTRA_Solution_Presentation.pptx
@@ -2030,7 +2030,7 @@
                 <a:ea typeface="Calibri" pitchFamily="34" charset="-122"/>
                 <a:cs typeface="Calibri" pitchFamily="34" charset="-120"/>
               </a:rPr>
-              <a:t>Category 1 · Individual entry · Lavesh Paryani</a:t>
+              <a:t>Category 1 · Lavesh Paryani and Hiral Kotwani</a:t>
             </a:r>
             <a:endParaRPr lang="en-US" sz="1300" dirty="0"/>
           </a:p>
@@ -2313,7 +2313,7 @@
                 <a:ea typeface="Cambria" pitchFamily="34" charset="-122"/>
                 <a:cs typeface="Cambria" pitchFamily="34" charset="-120"/>
               </a:rPr>
-              <a:t>174</a:t>
+              <a:t>175</a:t>
             </a:r>
             <a:endParaRPr lang="en-US" sz="2500" dirty="0"/>
           </a:p>
@@ -4227,7 +4227,7 @@
                 <a:ea typeface="Calibri" pitchFamily="34" charset="-122"/>
                 <a:cs typeface="Calibri" pitchFamily="34" charset="-120"/>
               </a:rPr>
-              <a:t>17/17 live API endpoints green · 174 automated tests passing · zero duplicate records · real accumulated data from the government feeds</a:t>
+              <a:t>17/17 live API endpoints green · 175 automated tests passing · zero duplicate records · real accumulated data from the government feeds</a:t>
             </a:r>
             <a:endParaRPr lang="en-US" sz="1250" dirty="0"/>
           </a:p>

</xml_diff>